<commit_message>
Use Helvetica for planner UI and exports
</commit_message>
<xml_diff>
--- a/examples/sample-export.pptx
+++ b/examples/sample-export.pptx
@@ -931,9 +931,9 @@
                 <a:solidFill>
                   <a:srgbClr val="6E8678"/>
                 </a:solidFill>
-                <a:latin typeface="Arial" pitchFamily="34" charset="0"/>
-                <a:ea typeface="Arial" pitchFamily="34" charset="-122"/>
-                <a:cs typeface="Arial" pitchFamily="34" charset="-120"/>
+                <a:latin typeface="Helvetica" pitchFamily="34" charset="0"/>
+                <a:ea typeface="Helvetica" pitchFamily="34" charset="-122"/>
+                <a:cs typeface="Helvetica" pitchFamily="34" charset="-120"/>
               </a:rPr>
               <a:t>ПЛАН РАЗРАБОТКИ СТРАНИЦ ПОРТАЛА</a:t>
             </a:r>
@@ -970,9 +970,9 @@
                 <a:solidFill>
                   <a:srgbClr val="183A30"/>
                 </a:solidFill>
-                <a:latin typeface="Arial" pitchFamily="34" charset="0"/>
-                <a:ea typeface="Arial" pitchFamily="34" charset="-122"/>
-                <a:cs typeface="Arial" pitchFamily="34" charset="-120"/>
+                <a:latin typeface="Helvetica" pitchFamily="34" charset="0"/>
+                <a:ea typeface="Helvetica" pitchFamily="34" charset="-122"/>
+                <a:cs typeface="Helvetica" pitchFamily="34" charset="-120"/>
               </a:rPr>
               <a:t>Пример недельного плана</a:t>
             </a:r>
@@ -1009,9 +1009,9 @@
                 <a:solidFill>
                   <a:srgbClr val="183A30"/>
                 </a:solidFill>
-                <a:latin typeface="Arial" pitchFamily="34" charset="0"/>
-                <a:ea typeface="Arial" pitchFamily="34" charset="-122"/>
-                <a:cs typeface="Arial" pitchFamily="34" charset="-120"/>
+                <a:latin typeface="Helvetica" pitchFamily="34" charset="0"/>
+                <a:ea typeface="Helvetica" pitchFamily="34" charset="-122"/>
+                <a:cs typeface="Helvetica" pitchFamily="34" charset="-120"/>
               </a:rPr>
               <a:t>ОТЧЁТ ОТ 21.09.2026</a:t>
             </a:r>
@@ -1048,9 +1048,9 @@
                 <a:solidFill>
                   <a:srgbClr val="6E8678"/>
                 </a:solidFill>
-                <a:latin typeface="Arial" pitchFamily="34" charset="0"/>
-                <a:ea typeface="Arial" pitchFamily="34" charset="-122"/>
-                <a:cs typeface="Arial" pitchFamily="34" charset="-120"/>
+                <a:latin typeface="Helvetica" pitchFamily="34" charset="0"/>
+                <a:ea typeface="Helvetica" pitchFamily="34" charset="-122"/>
+                <a:cs typeface="Helvetica" pitchFamily="34" charset="-120"/>
               </a:rPr>
               <a:t>21.09.2026 — 04.10.2026</a:t>
             </a:r>
@@ -1110,9 +1110,9 @@
                 <a:solidFill>
                   <a:srgbClr val="6E8678"/>
                 </a:solidFill>
-                <a:latin typeface="Arial" pitchFamily="34" charset="0"/>
-                <a:ea typeface="Arial" pitchFamily="34" charset="-122"/>
-                <a:cs typeface="Arial" pitchFamily="34" charset="-120"/>
+                <a:latin typeface="Helvetica" pitchFamily="34" charset="0"/>
+                <a:ea typeface="Helvetica" pitchFamily="34" charset="-122"/>
+                <a:cs typeface="Helvetica" pitchFamily="34" charset="-120"/>
               </a:rPr>
               <a:t>СОТРУДНИК / ЗАДАЧА</a:t>
             </a:r>
@@ -1149,9 +1149,9 @@
                 <a:solidFill>
                   <a:srgbClr val="183A30"/>
                 </a:solidFill>
-                <a:latin typeface="Arial" pitchFamily="34" charset="0"/>
-                <a:ea typeface="Arial" pitchFamily="34" charset="-122"/>
-                <a:cs typeface="Arial" pitchFamily="34" charset="-120"/>
+                <a:latin typeface="Helvetica" pitchFamily="34" charset="0"/>
+                <a:ea typeface="Helvetica" pitchFamily="34" charset="-122"/>
+                <a:cs typeface="Helvetica" pitchFamily="34" charset="-120"/>
               </a:rPr>
               <a:t>21–27 сентябрь</a:t>
             </a:r>
@@ -1188,9 +1188,9 @@
                 <a:solidFill>
                   <a:srgbClr val="183A30"/>
                 </a:solidFill>
-                <a:latin typeface="Arial" pitchFamily="34" charset="0"/>
-                <a:ea typeface="Arial" pitchFamily="34" charset="-122"/>
-                <a:cs typeface="Arial" pitchFamily="34" charset="-120"/>
+                <a:latin typeface="Helvetica" pitchFamily="34" charset="0"/>
+                <a:ea typeface="Helvetica" pitchFamily="34" charset="-122"/>
+                <a:cs typeface="Helvetica" pitchFamily="34" charset="-120"/>
               </a:rPr>
               <a:t>21</a:t>
             </a:r>
@@ -1250,9 +1250,9 @@
                 <a:solidFill>
                   <a:srgbClr val="183A30"/>
                 </a:solidFill>
-                <a:latin typeface="Arial" pitchFamily="34" charset="0"/>
-                <a:ea typeface="Arial" pitchFamily="34" charset="-122"/>
-                <a:cs typeface="Arial" pitchFamily="34" charset="-120"/>
+                <a:latin typeface="Helvetica" pitchFamily="34" charset="0"/>
+                <a:ea typeface="Helvetica" pitchFamily="34" charset="-122"/>
+                <a:cs typeface="Helvetica" pitchFamily="34" charset="-120"/>
               </a:rPr>
               <a:t>22</a:t>
             </a:r>
@@ -1312,9 +1312,9 @@
                 <a:solidFill>
                   <a:srgbClr val="183A30"/>
                 </a:solidFill>
-                <a:latin typeface="Arial" pitchFamily="34" charset="0"/>
-                <a:ea typeface="Arial" pitchFamily="34" charset="-122"/>
-                <a:cs typeface="Arial" pitchFamily="34" charset="-120"/>
+                <a:latin typeface="Helvetica" pitchFamily="34" charset="0"/>
+                <a:ea typeface="Helvetica" pitchFamily="34" charset="-122"/>
+                <a:cs typeface="Helvetica" pitchFamily="34" charset="-120"/>
               </a:rPr>
               <a:t>23</a:t>
             </a:r>
@@ -1374,9 +1374,9 @@
                 <a:solidFill>
                   <a:srgbClr val="183A30"/>
                 </a:solidFill>
-                <a:latin typeface="Arial" pitchFamily="34" charset="0"/>
-                <a:ea typeface="Arial" pitchFamily="34" charset="-122"/>
-                <a:cs typeface="Arial" pitchFamily="34" charset="-120"/>
+                <a:latin typeface="Helvetica" pitchFamily="34" charset="0"/>
+                <a:ea typeface="Helvetica" pitchFamily="34" charset="-122"/>
+                <a:cs typeface="Helvetica" pitchFamily="34" charset="-120"/>
               </a:rPr>
               <a:t>24</a:t>
             </a:r>
@@ -1436,9 +1436,9 @@
                 <a:solidFill>
                   <a:srgbClr val="183A30"/>
                 </a:solidFill>
-                <a:latin typeface="Arial" pitchFamily="34" charset="0"/>
-                <a:ea typeface="Arial" pitchFamily="34" charset="-122"/>
-                <a:cs typeface="Arial" pitchFamily="34" charset="-120"/>
+                <a:latin typeface="Helvetica" pitchFamily="34" charset="0"/>
+                <a:ea typeface="Helvetica" pitchFamily="34" charset="-122"/>
+                <a:cs typeface="Helvetica" pitchFamily="34" charset="-120"/>
               </a:rPr>
               <a:t>25</a:t>
             </a:r>
@@ -1525,9 +1525,9 @@
                 <a:solidFill>
                   <a:srgbClr val="8EA094"/>
                 </a:solidFill>
-                <a:latin typeface="Arial" pitchFamily="34" charset="0"/>
-                <a:ea typeface="Arial" pitchFamily="34" charset="-122"/>
-                <a:cs typeface="Arial" pitchFamily="34" charset="-120"/>
+                <a:latin typeface="Helvetica" pitchFamily="34" charset="0"/>
+                <a:ea typeface="Helvetica" pitchFamily="34" charset="-122"/>
+                <a:cs typeface="Helvetica" pitchFamily="34" charset="-120"/>
               </a:rPr>
               <a:t>26</a:t>
             </a:r>
@@ -1614,9 +1614,9 @@
                 <a:solidFill>
                   <a:srgbClr val="8EA094"/>
                 </a:solidFill>
-                <a:latin typeface="Arial" pitchFamily="34" charset="0"/>
-                <a:ea typeface="Arial" pitchFamily="34" charset="-122"/>
-                <a:cs typeface="Arial" pitchFamily="34" charset="-120"/>
+                <a:latin typeface="Helvetica" pitchFamily="34" charset="0"/>
+                <a:ea typeface="Helvetica" pitchFamily="34" charset="-122"/>
+                <a:cs typeface="Helvetica" pitchFamily="34" charset="-120"/>
               </a:rPr>
               <a:t>27</a:t>
             </a:r>
@@ -1676,9 +1676,9 @@
                 <a:solidFill>
                   <a:srgbClr val="183A30"/>
                 </a:solidFill>
-                <a:latin typeface="Arial" pitchFamily="34" charset="0"/>
-                <a:ea typeface="Arial" pitchFamily="34" charset="-122"/>
-                <a:cs typeface="Arial" pitchFamily="34" charset="-120"/>
+                <a:latin typeface="Helvetica" pitchFamily="34" charset="0"/>
+                <a:ea typeface="Helvetica" pitchFamily="34" charset="-122"/>
+                <a:cs typeface="Helvetica" pitchFamily="34" charset="-120"/>
               </a:rPr>
               <a:t>28–4 октябрь</a:t>
             </a:r>
@@ -1715,9 +1715,9 @@
                 <a:solidFill>
                   <a:srgbClr val="183A30"/>
                 </a:solidFill>
-                <a:latin typeface="Arial" pitchFamily="34" charset="0"/>
-                <a:ea typeface="Arial" pitchFamily="34" charset="-122"/>
-                <a:cs typeface="Arial" pitchFamily="34" charset="-120"/>
+                <a:latin typeface="Helvetica" pitchFamily="34" charset="0"/>
+                <a:ea typeface="Helvetica" pitchFamily="34" charset="-122"/>
+                <a:cs typeface="Helvetica" pitchFamily="34" charset="-120"/>
               </a:rPr>
               <a:t>28</a:t>
             </a:r>
@@ -1777,9 +1777,9 @@
                 <a:solidFill>
                   <a:srgbClr val="183A30"/>
                 </a:solidFill>
-                <a:latin typeface="Arial" pitchFamily="34" charset="0"/>
-                <a:ea typeface="Arial" pitchFamily="34" charset="-122"/>
-                <a:cs typeface="Arial" pitchFamily="34" charset="-120"/>
+                <a:latin typeface="Helvetica" pitchFamily="34" charset="0"/>
+                <a:ea typeface="Helvetica" pitchFamily="34" charset="-122"/>
+                <a:cs typeface="Helvetica" pitchFamily="34" charset="-120"/>
               </a:rPr>
               <a:t>29</a:t>
             </a:r>
@@ -1839,9 +1839,9 @@
                 <a:solidFill>
                   <a:srgbClr val="183A30"/>
                 </a:solidFill>
-                <a:latin typeface="Arial" pitchFamily="34" charset="0"/>
-                <a:ea typeface="Arial" pitchFamily="34" charset="-122"/>
-                <a:cs typeface="Arial" pitchFamily="34" charset="-120"/>
+                <a:latin typeface="Helvetica" pitchFamily="34" charset="0"/>
+                <a:ea typeface="Helvetica" pitchFamily="34" charset="-122"/>
+                <a:cs typeface="Helvetica" pitchFamily="34" charset="-120"/>
               </a:rPr>
               <a:t>30</a:t>
             </a:r>
@@ -1901,9 +1901,9 @@
                 <a:solidFill>
                   <a:srgbClr val="183A30"/>
                 </a:solidFill>
-                <a:latin typeface="Arial" pitchFamily="34" charset="0"/>
-                <a:ea typeface="Arial" pitchFamily="34" charset="-122"/>
-                <a:cs typeface="Arial" pitchFamily="34" charset="-120"/>
+                <a:latin typeface="Helvetica" pitchFamily="34" charset="0"/>
+                <a:ea typeface="Helvetica" pitchFamily="34" charset="-122"/>
+                <a:cs typeface="Helvetica" pitchFamily="34" charset="-120"/>
               </a:rPr>
               <a:t>1</a:t>
             </a:r>
@@ -1963,9 +1963,9 @@
                 <a:solidFill>
                   <a:srgbClr val="183A30"/>
                 </a:solidFill>
-                <a:latin typeface="Arial" pitchFamily="34" charset="0"/>
-                <a:ea typeface="Arial" pitchFamily="34" charset="-122"/>
-                <a:cs typeface="Arial" pitchFamily="34" charset="-120"/>
+                <a:latin typeface="Helvetica" pitchFamily="34" charset="0"/>
+                <a:ea typeface="Helvetica" pitchFamily="34" charset="-122"/>
+                <a:cs typeface="Helvetica" pitchFamily="34" charset="-120"/>
               </a:rPr>
               <a:t>2</a:t>
             </a:r>
@@ -2052,9 +2052,9 @@
                 <a:solidFill>
                   <a:srgbClr val="8EA094"/>
                 </a:solidFill>
-                <a:latin typeface="Arial" pitchFamily="34" charset="0"/>
-                <a:ea typeface="Arial" pitchFamily="34" charset="-122"/>
-                <a:cs typeface="Arial" pitchFamily="34" charset="-120"/>
+                <a:latin typeface="Helvetica" pitchFamily="34" charset="0"/>
+                <a:ea typeface="Helvetica" pitchFamily="34" charset="-122"/>
+                <a:cs typeface="Helvetica" pitchFamily="34" charset="-120"/>
               </a:rPr>
               <a:t>3</a:t>
             </a:r>
@@ -2141,9 +2141,9 @@
                 <a:solidFill>
                   <a:srgbClr val="8EA094"/>
                 </a:solidFill>
-                <a:latin typeface="Arial" pitchFamily="34" charset="0"/>
-                <a:ea typeface="Arial" pitchFamily="34" charset="-122"/>
-                <a:cs typeface="Arial" pitchFamily="34" charset="-120"/>
+                <a:latin typeface="Helvetica" pitchFamily="34" charset="0"/>
+                <a:ea typeface="Helvetica" pitchFamily="34" charset="-122"/>
+                <a:cs typeface="Helvetica" pitchFamily="34" charset="-120"/>
               </a:rPr>
               <a:t>4</a:t>
             </a:r>
@@ -2276,9 +2276,9 @@
                 <a:solidFill>
                   <a:srgbClr val="183A30"/>
                 </a:solidFill>
-                <a:latin typeface="Arial" pitchFamily="34" charset="0"/>
-                <a:ea typeface="Arial" pitchFamily="34" charset="-122"/>
-                <a:cs typeface="Arial" pitchFamily="34" charset="-120"/>
+                <a:latin typeface="Helvetica" pitchFamily="34" charset="0"/>
+                <a:ea typeface="Helvetica" pitchFamily="34" charset="-122"/>
+                <a:cs typeface="Helvetica" pitchFamily="34" charset="-120"/>
               </a:rPr>
               <a:t>Сотрудник 1</a:t>
             </a:r>
@@ -2315,9 +2315,9 @@
                 <a:solidFill>
                   <a:srgbClr val="6E8678"/>
                 </a:solidFill>
-                <a:latin typeface="Arial" pitchFamily="34" charset="0"/>
-                <a:ea typeface="Arial" pitchFamily="34" charset="-122"/>
-                <a:cs typeface="Arial" pitchFamily="34" charset="-120"/>
+                <a:latin typeface="Helvetica" pitchFamily="34" charset="0"/>
+                <a:ea typeface="Helvetica" pitchFamily="34" charset="-122"/>
+                <a:cs typeface="Helvetica" pitchFamily="34" charset="-120"/>
               </a:rPr>
               <a:t>ВЕРСТКА</a:t>
             </a:r>
@@ -2377,9 +2377,9 @@
                 <a:solidFill>
                   <a:srgbClr val="183A30"/>
                 </a:solidFill>
-                <a:latin typeface="Arial" pitchFamily="34" charset="0"/>
-                <a:ea typeface="Arial" pitchFamily="34" charset="-122"/>
-                <a:cs typeface="Arial" pitchFamily="34" charset="-120"/>
+                <a:latin typeface="Helvetica" pitchFamily="34" charset="0"/>
+                <a:ea typeface="Helvetica" pitchFamily="34" charset="-122"/>
+                <a:cs typeface="Helvetica" pitchFamily="34" charset="-120"/>
               </a:rPr>
               <a:t>Верстка страницы</a:t>
             </a:r>
@@ -2445,9 +2445,9 @@
                 <a:solidFill>
                   <a:srgbClr val="FFFFFF"/>
                 </a:solidFill>
-                <a:latin typeface="Arial" pitchFamily="34" charset="0"/>
-                <a:ea typeface="Arial" pitchFamily="34" charset="-122"/>
-                <a:cs typeface="Arial" pitchFamily="34" charset="-120"/>
+                <a:latin typeface="Helvetica" pitchFamily="34" charset="0"/>
+                <a:ea typeface="Helvetica" pitchFamily="34" charset="-122"/>
+                <a:cs typeface="Helvetica" pitchFamily="34" charset="-120"/>
               </a:rPr>
               <a:t>Верстка</a:t>
             </a:r>
@@ -2534,9 +2534,9 @@
                 <a:solidFill>
                   <a:srgbClr val="183A30"/>
                 </a:solidFill>
-                <a:latin typeface="Arial" pitchFamily="34" charset="0"/>
-                <a:ea typeface="Arial" pitchFamily="34" charset="-122"/>
-                <a:cs typeface="Arial" pitchFamily="34" charset="-120"/>
+                <a:latin typeface="Helvetica" pitchFamily="34" charset="0"/>
+                <a:ea typeface="Helvetica" pitchFamily="34" charset="-122"/>
+                <a:cs typeface="Helvetica" pitchFamily="34" charset="-120"/>
               </a:rPr>
               <a:t>Сотрудник 2</a:t>
             </a:r>
@@ -2573,9 +2573,9 @@
                 <a:solidFill>
                   <a:srgbClr val="6E8678"/>
                 </a:solidFill>
-                <a:latin typeface="Arial" pitchFamily="34" charset="0"/>
-                <a:ea typeface="Arial" pitchFamily="34" charset="-122"/>
-                <a:cs typeface="Arial" pitchFamily="34" charset="-120"/>
+                <a:latin typeface="Helvetica" pitchFamily="34" charset="0"/>
+                <a:ea typeface="Helvetica" pitchFamily="34" charset="-122"/>
+                <a:cs typeface="Helvetica" pitchFamily="34" charset="-120"/>
               </a:rPr>
               <a:t>ВЕРСТКА</a:t>
             </a:r>
@@ -2662,9 +2662,9 @@
                 <a:solidFill>
                   <a:srgbClr val="183A30"/>
                 </a:solidFill>
-                <a:latin typeface="Arial" pitchFamily="34" charset="0"/>
-                <a:ea typeface="Arial" pitchFamily="34" charset="-122"/>
-                <a:cs typeface="Arial" pitchFamily="34" charset="-120"/>
+                <a:latin typeface="Helvetica" pitchFamily="34" charset="0"/>
+                <a:ea typeface="Helvetica" pitchFamily="34" charset="-122"/>
+                <a:cs typeface="Helvetica" pitchFamily="34" charset="-120"/>
               </a:rPr>
               <a:t>Сотрудник 3</a:t>
             </a:r>
@@ -2701,9 +2701,9 @@
                 <a:solidFill>
                   <a:srgbClr val="6E8678"/>
                 </a:solidFill>
-                <a:latin typeface="Arial" pitchFamily="34" charset="0"/>
-                <a:ea typeface="Arial" pitchFamily="34" charset="-122"/>
-                <a:cs typeface="Arial" pitchFamily="34" charset="-120"/>
+                <a:latin typeface="Helvetica" pitchFamily="34" charset="0"/>
+                <a:ea typeface="Helvetica" pitchFamily="34" charset="-122"/>
+                <a:cs typeface="Helvetica" pitchFamily="34" charset="-120"/>
               </a:rPr>
               <a:t>ДИЗАЙН</a:t>
             </a:r>
@@ -2763,9 +2763,9 @@
                 <a:solidFill>
                   <a:srgbClr val="183A30"/>
                 </a:solidFill>
-                <a:latin typeface="Arial" pitchFamily="34" charset="0"/>
-                <a:ea typeface="Arial" pitchFamily="34" charset="-122"/>
-                <a:cs typeface="Arial" pitchFamily="34" charset="-120"/>
+                <a:latin typeface="Helvetica" pitchFamily="34" charset="0"/>
+                <a:ea typeface="Helvetica" pitchFamily="34" charset="-122"/>
+                <a:cs typeface="Helvetica" pitchFamily="34" charset="-120"/>
               </a:rPr>
               <a:t>Дизайн страницы</a:t>
             </a:r>
@@ -2831,9 +2831,9 @@
                 <a:solidFill>
                   <a:srgbClr val="FFFFFF"/>
                 </a:solidFill>
-                <a:latin typeface="Arial" pitchFamily="34" charset="0"/>
-                <a:ea typeface="Arial" pitchFamily="34" charset="-122"/>
-                <a:cs typeface="Arial" pitchFamily="34" charset="-120"/>
+                <a:latin typeface="Helvetica" pitchFamily="34" charset="0"/>
+                <a:ea typeface="Helvetica" pitchFamily="34" charset="-122"/>
+                <a:cs typeface="Helvetica" pitchFamily="34" charset="-120"/>
               </a:rPr>
               <a:t>Дизайн</a:t>
             </a:r>
@@ -2893,9 +2893,9 @@
                 <a:solidFill>
                   <a:srgbClr val="6E8678"/>
                 </a:solidFill>
-                <a:latin typeface="Arial" pitchFamily="34" charset="0"/>
-                <a:ea typeface="Arial" pitchFamily="34" charset="-122"/>
-                <a:cs typeface="Arial" pitchFamily="34" charset="-120"/>
+                <a:latin typeface="Helvetica" pitchFamily="34" charset="0"/>
+                <a:ea typeface="Helvetica" pitchFamily="34" charset="-122"/>
+                <a:cs typeface="Helvetica" pitchFamily="34" charset="-120"/>
               </a:rPr>
               <a:t>СОСТОЯНИЕ ЗАДАЧ</a:t>
             </a:r>
@@ -2961,9 +2961,9 @@
                 <a:solidFill>
                   <a:srgbClr val="6E8678"/>
                 </a:solidFill>
-                <a:latin typeface="Arial" pitchFamily="34" charset="0"/>
-                <a:ea typeface="Arial" pitchFamily="34" charset="-122"/>
-                <a:cs typeface="Arial" pitchFamily="34" charset="-120"/>
+                <a:latin typeface="Helvetica" pitchFamily="34" charset="0"/>
+                <a:ea typeface="Helvetica" pitchFamily="34" charset="-122"/>
+                <a:cs typeface="Helvetica" pitchFamily="34" charset="-120"/>
               </a:rPr>
               <a:t>Ожидает</a:t>
             </a:r>
@@ -3029,9 +3029,9 @@
                 <a:solidFill>
                   <a:srgbClr val="6E8678"/>
                 </a:solidFill>
-                <a:latin typeface="Arial" pitchFamily="34" charset="0"/>
-                <a:ea typeface="Arial" pitchFamily="34" charset="-122"/>
-                <a:cs typeface="Arial" pitchFamily="34" charset="-120"/>
+                <a:latin typeface="Helvetica" pitchFamily="34" charset="0"/>
+                <a:ea typeface="Helvetica" pitchFamily="34" charset="-122"/>
+                <a:cs typeface="Helvetica" pitchFamily="34" charset="-120"/>
               </a:rPr>
               <a:t>В работе</a:t>
             </a:r>
@@ -3097,9 +3097,9 @@
                 <a:solidFill>
                   <a:srgbClr val="6E8678"/>
                 </a:solidFill>
-                <a:latin typeface="Arial" pitchFamily="34" charset="0"/>
-                <a:ea typeface="Arial" pitchFamily="34" charset="-122"/>
-                <a:cs typeface="Arial" pitchFamily="34" charset="-120"/>
+                <a:latin typeface="Helvetica" pitchFamily="34" charset="0"/>
+                <a:ea typeface="Helvetica" pitchFamily="34" charset="-122"/>
+                <a:cs typeface="Helvetica" pitchFamily="34" charset="-120"/>
               </a:rPr>
               <a:t>Выполнена</a:t>
             </a:r>
@@ -3165,9 +3165,9 @@
                 <a:solidFill>
                   <a:srgbClr val="6E8678"/>
                 </a:solidFill>
-                <a:latin typeface="Arial" pitchFamily="34" charset="0"/>
-                <a:ea typeface="Arial" pitchFamily="34" charset="-122"/>
-                <a:cs typeface="Arial" pitchFamily="34" charset="-120"/>
+                <a:latin typeface="Helvetica" pitchFamily="34" charset="0"/>
+                <a:ea typeface="Helvetica" pitchFamily="34" charset="-122"/>
+                <a:cs typeface="Helvetica" pitchFamily="34" charset="-120"/>
               </a:rPr>
               <a:t>Текучка</a:t>
             </a:r>
@@ -3204,9 +3204,9 @@
                 <a:solidFill>
                   <a:srgbClr val="6E8678"/>
                 </a:solidFill>
-                <a:latin typeface="Arial" pitchFamily="34" charset="0"/>
-                <a:ea typeface="Arial" pitchFamily="34" charset="-122"/>
-                <a:cs typeface="Arial" pitchFamily="34" charset="-120"/>
+                <a:latin typeface="Helvetica" pitchFamily="34" charset="0"/>
+                <a:ea typeface="Helvetica" pitchFamily="34" charset="-122"/>
+                <a:cs typeface="Helvetica" pitchFamily="34" charset="-120"/>
               </a:rPr>
               <a:t>1 / 1</a:t>
             </a:r>

</xml_diff>

<commit_message>
Use Century Gothic and group weekly routine on one row
</commit_message>
<xml_diff>
--- a/examples/sample-export.pptx
+++ b/examples/sample-export.pptx
@@ -931,9 +931,9 @@
                 <a:solidFill>
                   <a:srgbClr val="6E8678"/>
                 </a:solidFill>
-                <a:latin typeface="Helvetica" pitchFamily="34" charset="0"/>
-                <a:ea typeface="Helvetica" pitchFamily="34" charset="-122"/>
-                <a:cs typeface="Helvetica" pitchFamily="34" charset="-120"/>
+                <a:latin typeface="Century Gothic" pitchFamily="34" charset="0"/>
+                <a:ea typeface="Century Gothic" pitchFamily="34" charset="-122"/>
+                <a:cs typeface="Century Gothic" pitchFamily="34" charset="-120"/>
               </a:rPr>
               <a:t>ПЛАН РАЗРАБОТКИ СТРАНИЦ ПОРТАЛА</a:t>
             </a:r>
@@ -970,9 +970,9 @@
                 <a:solidFill>
                   <a:srgbClr val="183A30"/>
                 </a:solidFill>
-                <a:latin typeface="Helvetica" pitchFamily="34" charset="0"/>
-                <a:ea typeface="Helvetica" pitchFamily="34" charset="-122"/>
-                <a:cs typeface="Helvetica" pitchFamily="34" charset="-120"/>
+                <a:latin typeface="Century Gothic" pitchFamily="34" charset="0"/>
+                <a:ea typeface="Century Gothic" pitchFamily="34" charset="-122"/>
+                <a:cs typeface="Century Gothic" pitchFamily="34" charset="-120"/>
               </a:rPr>
               <a:t>Пример недельного плана</a:t>
             </a:r>
@@ -1009,9 +1009,9 @@
                 <a:solidFill>
                   <a:srgbClr val="183A30"/>
                 </a:solidFill>
-                <a:latin typeface="Helvetica" pitchFamily="34" charset="0"/>
-                <a:ea typeface="Helvetica" pitchFamily="34" charset="-122"/>
-                <a:cs typeface="Helvetica" pitchFamily="34" charset="-120"/>
+                <a:latin typeface="Century Gothic" pitchFamily="34" charset="0"/>
+                <a:ea typeface="Century Gothic" pitchFamily="34" charset="-122"/>
+                <a:cs typeface="Century Gothic" pitchFamily="34" charset="-120"/>
               </a:rPr>
               <a:t>ОТЧЁТ ОТ 21.09.2026</a:t>
             </a:r>
@@ -1048,9 +1048,9 @@
                 <a:solidFill>
                   <a:srgbClr val="6E8678"/>
                 </a:solidFill>
-                <a:latin typeface="Helvetica" pitchFamily="34" charset="0"/>
-                <a:ea typeface="Helvetica" pitchFamily="34" charset="-122"/>
-                <a:cs typeface="Helvetica" pitchFamily="34" charset="-120"/>
+                <a:latin typeface="Century Gothic" pitchFamily="34" charset="0"/>
+                <a:ea typeface="Century Gothic" pitchFamily="34" charset="-122"/>
+                <a:cs typeface="Century Gothic" pitchFamily="34" charset="-120"/>
               </a:rPr>
               <a:t>21.09.2026 — 04.10.2026</a:t>
             </a:r>
@@ -1110,9 +1110,9 @@
                 <a:solidFill>
                   <a:srgbClr val="6E8678"/>
                 </a:solidFill>
-                <a:latin typeface="Helvetica" pitchFamily="34" charset="0"/>
-                <a:ea typeface="Helvetica" pitchFamily="34" charset="-122"/>
-                <a:cs typeface="Helvetica" pitchFamily="34" charset="-120"/>
+                <a:latin typeface="Century Gothic" pitchFamily="34" charset="0"/>
+                <a:ea typeface="Century Gothic" pitchFamily="34" charset="-122"/>
+                <a:cs typeface="Century Gothic" pitchFamily="34" charset="-120"/>
               </a:rPr>
               <a:t>СОТРУДНИК / ЗАДАЧА</a:t>
             </a:r>
@@ -1149,9 +1149,9 @@
                 <a:solidFill>
                   <a:srgbClr val="183A30"/>
                 </a:solidFill>
-                <a:latin typeface="Helvetica" pitchFamily="34" charset="0"/>
-                <a:ea typeface="Helvetica" pitchFamily="34" charset="-122"/>
-                <a:cs typeface="Helvetica" pitchFamily="34" charset="-120"/>
+                <a:latin typeface="Century Gothic" pitchFamily="34" charset="0"/>
+                <a:ea typeface="Century Gothic" pitchFamily="34" charset="-122"/>
+                <a:cs typeface="Century Gothic" pitchFamily="34" charset="-120"/>
               </a:rPr>
               <a:t>21–27 сентябрь</a:t>
             </a:r>
@@ -1188,9 +1188,9 @@
                 <a:solidFill>
                   <a:srgbClr val="183A30"/>
                 </a:solidFill>
-                <a:latin typeface="Helvetica" pitchFamily="34" charset="0"/>
-                <a:ea typeface="Helvetica" pitchFamily="34" charset="-122"/>
-                <a:cs typeface="Helvetica" pitchFamily="34" charset="-120"/>
+                <a:latin typeface="Century Gothic" pitchFamily="34" charset="0"/>
+                <a:ea typeface="Century Gothic" pitchFamily="34" charset="-122"/>
+                <a:cs typeface="Century Gothic" pitchFamily="34" charset="-120"/>
               </a:rPr>
               <a:t>21</a:t>
             </a:r>
@@ -1207,7 +1207,7 @@
         <p:spPr>
           <a:xfrm>
             <a:off x="3302000" y="1314450"/>
-            <a:ext cx="0" cy="914400"/>
+            <a:ext cx="0" cy="1447800"/>
           </a:xfrm>
           <a:prstGeom prst="line">
             <a:avLst/>
@@ -1250,9 +1250,9 @@
                 <a:solidFill>
                   <a:srgbClr val="183A30"/>
                 </a:solidFill>
-                <a:latin typeface="Helvetica" pitchFamily="34" charset="0"/>
-                <a:ea typeface="Helvetica" pitchFamily="34" charset="-122"/>
-                <a:cs typeface="Helvetica" pitchFamily="34" charset="-120"/>
+                <a:latin typeface="Century Gothic" pitchFamily="34" charset="0"/>
+                <a:ea typeface="Century Gothic" pitchFamily="34" charset="-122"/>
+                <a:cs typeface="Century Gothic" pitchFamily="34" charset="-120"/>
               </a:rPr>
               <a:t>22</a:t>
             </a:r>
@@ -1269,7 +1269,7 @@
         <p:spPr>
           <a:xfrm>
             <a:off x="3914321" y="1314450"/>
-            <a:ext cx="0" cy="914400"/>
+            <a:ext cx="0" cy="1447800"/>
           </a:xfrm>
           <a:prstGeom prst="line">
             <a:avLst/>
@@ -1312,9 +1312,9 @@
                 <a:solidFill>
                   <a:srgbClr val="183A30"/>
                 </a:solidFill>
-                <a:latin typeface="Helvetica" pitchFamily="34" charset="0"/>
-                <a:ea typeface="Helvetica" pitchFamily="34" charset="-122"/>
-                <a:cs typeface="Helvetica" pitchFamily="34" charset="-120"/>
+                <a:latin typeface="Century Gothic" pitchFamily="34" charset="0"/>
+                <a:ea typeface="Century Gothic" pitchFamily="34" charset="-122"/>
+                <a:cs typeface="Century Gothic" pitchFamily="34" charset="-120"/>
               </a:rPr>
               <a:t>23</a:t>
             </a:r>
@@ -1331,7 +1331,7 @@
         <p:spPr>
           <a:xfrm>
             <a:off x="4526643" y="1314450"/>
-            <a:ext cx="0" cy="914400"/>
+            <a:ext cx="0" cy="1447800"/>
           </a:xfrm>
           <a:prstGeom prst="line">
             <a:avLst/>
@@ -1374,9 +1374,9 @@
                 <a:solidFill>
                   <a:srgbClr val="183A30"/>
                 </a:solidFill>
-                <a:latin typeface="Helvetica" pitchFamily="34" charset="0"/>
-                <a:ea typeface="Helvetica" pitchFamily="34" charset="-122"/>
-                <a:cs typeface="Helvetica" pitchFamily="34" charset="-120"/>
+                <a:latin typeface="Century Gothic" pitchFamily="34" charset="0"/>
+                <a:ea typeface="Century Gothic" pitchFamily="34" charset="-122"/>
+                <a:cs typeface="Century Gothic" pitchFamily="34" charset="-120"/>
               </a:rPr>
               <a:t>24</a:t>
             </a:r>
@@ -1393,7 +1393,7 @@
         <p:spPr>
           <a:xfrm>
             <a:off x="5138964" y="1314450"/>
-            <a:ext cx="0" cy="914400"/>
+            <a:ext cx="0" cy="1447800"/>
           </a:xfrm>
           <a:prstGeom prst="line">
             <a:avLst/>
@@ -1436,9 +1436,9 @@
                 <a:solidFill>
                   <a:srgbClr val="183A30"/>
                 </a:solidFill>
-                <a:latin typeface="Helvetica" pitchFamily="34" charset="0"/>
-                <a:ea typeface="Helvetica" pitchFamily="34" charset="-122"/>
-                <a:cs typeface="Helvetica" pitchFamily="34" charset="-120"/>
+                <a:latin typeface="Century Gothic" pitchFamily="34" charset="0"/>
+                <a:ea typeface="Century Gothic" pitchFamily="34" charset="-122"/>
+                <a:cs typeface="Century Gothic" pitchFamily="34" charset="-120"/>
               </a:rPr>
               <a:t>25</a:t>
             </a:r>
@@ -1455,7 +1455,7 @@
         <p:spPr>
           <a:xfrm>
             <a:off x="5751286" y="1314450"/>
-            <a:ext cx="0" cy="914400"/>
+            <a:ext cx="0" cy="1447800"/>
           </a:xfrm>
           <a:prstGeom prst="line">
             <a:avLst/>
@@ -1525,9 +1525,9 @@
                 <a:solidFill>
                   <a:srgbClr val="8EA094"/>
                 </a:solidFill>
-                <a:latin typeface="Helvetica" pitchFamily="34" charset="0"/>
-                <a:ea typeface="Helvetica" pitchFamily="34" charset="-122"/>
-                <a:cs typeface="Helvetica" pitchFamily="34" charset="-120"/>
+                <a:latin typeface="Century Gothic" pitchFamily="34" charset="0"/>
+                <a:ea typeface="Century Gothic" pitchFamily="34" charset="-122"/>
+                <a:cs typeface="Century Gothic" pitchFamily="34" charset="-120"/>
               </a:rPr>
               <a:t>26</a:t>
             </a:r>
@@ -1544,7 +1544,7 @@
         <p:spPr>
           <a:xfrm>
             <a:off x="6363607" y="1314450"/>
-            <a:ext cx="0" cy="914400"/>
+            <a:ext cx="0" cy="1447800"/>
           </a:xfrm>
           <a:prstGeom prst="line">
             <a:avLst/>
@@ -1614,9 +1614,9 @@
                 <a:solidFill>
                   <a:srgbClr val="8EA094"/>
                 </a:solidFill>
-                <a:latin typeface="Helvetica" pitchFamily="34" charset="0"/>
-                <a:ea typeface="Helvetica" pitchFamily="34" charset="-122"/>
-                <a:cs typeface="Helvetica" pitchFamily="34" charset="-120"/>
+                <a:latin typeface="Century Gothic" pitchFamily="34" charset="0"/>
+                <a:ea typeface="Century Gothic" pitchFamily="34" charset="-122"/>
+                <a:cs typeface="Century Gothic" pitchFamily="34" charset="-120"/>
               </a:rPr>
               <a:t>27</a:t>
             </a:r>
@@ -1633,7 +1633,7 @@
         <p:spPr>
           <a:xfrm>
             <a:off x="6975929" y="1314450"/>
-            <a:ext cx="0" cy="914400"/>
+            <a:ext cx="0" cy="1447800"/>
           </a:xfrm>
           <a:prstGeom prst="line">
             <a:avLst/>
@@ -1676,9 +1676,9 @@
                 <a:solidFill>
                   <a:srgbClr val="183A30"/>
                 </a:solidFill>
-                <a:latin typeface="Helvetica" pitchFamily="34" charset="0"/>
-                <a:ea typeface="Helvetica" pitchFamily="34" charset="-122"/>
-                <a:cs typeface="Helvetica" pitchFamily="34" charset="-120"/>
+                <a:latin typeface="Century Gothic" pitchFamily="34" charset="0"/>
+                <a:ea typeface="Century Gothic" pitchFamily="34" charset="-122"/>
+                <a:cs typeface="Century Gothic" pitchFamily="34" charset="-120"/>
               </a:rPr>
               <a:t>28–4 октябрь</a:t>
             </a:r>
@@ -1715,9 +1715,9 @@
                 <a:solidFill>
                   <a:srgbClr val="183A30"/>
                 </a:solidFill>
-                <a:latin typeface="Helvetica" pitchFamily="34" charset="0"/>
-                <a:ea typeface="Helvetica" pitchFamily="34" charset="-122"/>
-                <a:cs typeface="Helvetica" pitchFamily="34" charset="-120"/>
+                <a:latin typeface="Century Gothic" pitchFamily="34" charset="0"/>
+                <a:ea typeface="Century Gothic" pitchFamily="34" charset="-122"/>
+                <a:cs typeface="Century Gothic" pitchFamily="34" charset="-120"/>
               </a:rPr>
               <a:t>28</a:t>
             </a:r>
@@ -1734,7 +1734,7 @@
         <p:spPr>
           <a:xfrm>
             <a:off x="7588250" y="1314450"/>
-            <a:ext cx="0" cy="914400"/>
+            <a:ext cx="0" cy="1447800"/>
           </a:xfrm>
           <a:prstGeom prst="line">
             <a:avLst/>
@@ -1777,9 +1777,9 @@
                 <a:solidFill>
                   <a:srgbClr val="183A30"/>
                 </a:solidFill>
-                <a:latin typeface="Helvetica" pitchFamily="34" charset="0"/>
-                <a:ea typeface="Helvetica" pitchFamily="34" charset="-122"/>
-                <a:cs typeface="Helvetica" pitchFamily="34" charset="-120"/>
+                <a:latin typeface="Century Gothic" pitchFamily="34" charset="0"/>
+                <a:ea typeface="Century Gothic" pitchFamily="34" charset="-122"/>
+                <a:cs typeface="Century Gothic" pitchFamily="34" charset="-120"/>
               </a:rPr>
               <a:t>29</a:t>
             </a:r>
@@ -1796,7 +1796,7 @@
         <p:spPr>
           <a:xfrm>
             <a:off x="8200571" y="1314450"/>
-            <a:ext cx="0" cy="914400"/>
+            <a:ext cx="0" cy="1447800"/>
           </a:xfrm>
           <a:prstGeom prst="line">
             <a:avLst/>
@@ -1839,9 +1839,9 @@
                 <a:solidFill>
                   <a:srgbClr val="183A30"/>
                 </a:solidFill>
-                <a:latin typeface="Helvetica" pitchFamily="34" charset="0"/>
-                <a:ea typeface="Helvetica" pitchFamily="34" charset="-122"/>
-                <a:cs typeface="Helvetica" pitchFamily="34" charset="-120"/>
+                <a:latin typeface="Century Gothic" pitchFamily="34" charset="0"/>
+                <a:ea typeface="Century Gothic" pitchFamily="34" charset="-122"/>
+                <a:cs typeface="Century Gothic" pitchFamily="34" charset="-120"/>
               </a:rPr>
               <a:t>30</a:t>
             </a:r>
@@ -1858,7 +1858,7 @@
         <p:spPr>
           <a:xfrm>
             <a:off x="8812893" y="1314450"/>
-            <a:ext cx="0" cy="914400"/>
+            <a:ext cx="0" cy="1447800"/>
           </a:xfrm>
           <a:prstGeom prst="line">
             <a:avLst/>
@@ -1901,9 +1901,9 @@
                 <a:solidFill>
                   <a:srgbClr val="183A30"/>
                 </a:solidFill>
-                <a:latin typeface="Helvetica" pitchFamily="34" charset="0"/>
-                <a:ea typeface="Helvetica" pitchFamily="34" charset="-122"/>
-                <a:cs typeface="Helvetica" pitchFamily="34" charset="-120"/>
+                <a:latin typeface="Century Gothic" pitchFamily="34" charset="0"/>
+                <a:ea typeface="Century Gothic" pitchFamily="34" charset="-122"/>
+                <a:cs typeface="Century Gothic" pitchFamily="34" charset="-120"/>
               </a:rPr>
               <a:t>1</a:t>
             </a:r>
@@ -1920,7 +1920,7 @@
         <p:spPr>
           <a:xfrm>
             <a:off x="9425214" y="1314450"/>
-            <a:ext cx="0" cy="914400"/>
+            <a:ext cx="0" cy="1447800"/>
           </a:xfrm>
           <a:prstGeom prst="line">
             <a:avLst/>
@@ -1963,9 +1963,9 @@
                 <a:solidFill>
                   <a:srgbClr val="183A30"/>
                 </a:solidFill>
-                <a:latin typeface="Helvetica" pitchFamily="34" charset="0"/>
-                <a:ea typeface="Helvetica" pitchFamily="34" charset="-122"/>
-                <a:cs typeface="Helvetica" pitchFamily="34" charset="-120"/>
+                <a:latin typeface="Century Gothic" pitchFamily="34" charset="0"/>
+                <a:ea typeface="Century Gothic" pitchFamily="34" charset="-122"/>
+                <a:cs typeface="Century Gothic" pitchFamily="34" charset="-120"/>
               </a:rPr>
               <a:t>2</a:t>
             </a:r>
@@ -1982,7 +1982,7 @@
         <p:spPr>
           <a:xfrm>
             <a:off x="10037536" y="1314450"/>
-            <a:ext cx="0" cy="914400"/>
+            <a:ext cx="0" cy="1447800"/>
           </a:xfrm>
           <a:prstGeom prst="line">
             <a:avLst/>
@@ -2052,9 +2052,9 @@
                 <a:solidFill>
                   <a:srgbClr val="8EA094"/>
                 </a:solidFill>
-                <a:latin typeface="Helvetica" pitchFamily="34" charset="0"/>
-                <a:ea typeface="Helvetica" pitchFamily="34" charset="-122"/>
-                <a:cs typeface="Helvetica" pitchFamily="34" charset="-120"/>
+                <a:latin typeface="Century Gothic" pitchFamily="34" charset="0"/>
+                <a:ea typeface="Century Gothic" pitchFamily="34" charset="-122"/>
+                <a:cs typeface="Century Gothic" pitchFamily="34" charset="-120"/>
               </a:rPr>
               <a:t>3</a:t>
             </a:r>
@@ -2071,7 +2071,7 @@
         <p:spPr>
           <a:xfrm>
             <a:off x="10649857" y="1314450"/>
-            <a:ext cx="0" cy="914400"/>
+            <a:ext cx="0" cy="1447800"/>
           </a:xfrm>
           <a:prstGeom prst="line">
             <a:avLst/>
@@ -2141,9 +2141,9 @@
                 <a:solidFill>
                   <a:srgbClr val="8EA094"/>
                 </a:solidFill>
-                <a:latin typeface="Helvetica" pitchFamily="34" charset="0"/>
-                <a:ea typeface="Helvetica" pitchFamily="34" charset="-122"/>
-                <a:cs typeface="Helvetica" pitchFamily="34" charset="-120"/>
+                <a:latin typeface="Century Gothic" pitchFamily="34" charset="0"/>
+                <a:ea typeface="Century Gothic" pitchFamily="34" charset="-122"/>
+                <a:cs typeface="Century Gothic" pitchFamily="34" charset="-120"/>
               </a:rPr>
               <a:t>4</a:t>
             </a:r>
@@ -2160,7 +2160,7 @@
         <p:spPr>
           <a:xfrm>
             <a:off x="11262179" y="1314450"/>
-            <a:ext cx="0" cy="914400"/>
+            <a:ext cx="0" cy="1447800"/>
           </a:xfrm>
           <a:prstGeom prst="line">
             <a:avLst/>
@@ -2183,7 +2183,7 @@
         <p:spPr>
           <a:xfrm>
             <a:off x="11874500" y="1314450"/>
-            <a:ext cx="0" cy="914400"/>
+            <a:ext cx="0" cy="1447800"/>
           </a:xfrm>
           <a:prstGeom prst="line">
             <a:avLst/>
@@ -2276,9 +2276,9 @@
                 <a:solidFill>
                   <a:srgbClr val="183A30"/>
                 </a:solidFill>
-                <a:latin typeface="Helvetica" pitchFamily="34" charset="0"/>
-                <a:ea typeface="Helvetica" pitchFamily="34" charset="-122"/>
-                <a:cs typeface="Helvetica" pitchFamily="34" charset="-120"/>
+                <a:latin typeface="Century Gothic" pitchFamily="34" charset="0"/>
+                <a:ea typeface="Century Gothic" pitchFamily="34" charset="-122"/>
+                <a:cs typeface="Century Gothic" pitchFamily="34" charset="-120"/>
               </a:rPr>
               <a:t>Сотрудник 1</a:t>
             </a:r>
@@ -2315,9 +2315,9 @@
                 <a:solidFill>
                   <a:srgbClr val="6E8678"/>
                 </a:solidFill>
-                <a:latin typeface="Helvetica" pitchFamily="34" charset="0"/>
-                <a:ea typeface="Helvetica" pitchFamily="34" charset="-122"/>
-                <a:cs typeface="Helvetica" pitchFamily="34" charset="-120"/>
+                <a:latin typeface="Century Gothic" pitchFamily="34" charset="0"/>
+                <a:ea typeface="Century Gothic" pitchFamily="34" charset="-122"/>
+                <a:cs typeface="Century Gothic" pitchFamily="34" charset="-120"/>
               </a:rPr>
               <a:t>ВЕРСТКА</a:t>
             </a:r>
@@ -2377,9 +2377,9 @@
                 <a:solidFill>
                   <a:srgbClr val="183A30"/>
                 </a:solidFill>
-                <a:latin typeface="Helvetica" pitchFamily="34" charset="0"/>
-                <a:ea typeface="Helvetica" pitchFamily="34" charset="-122"/>
-                <a:cs typeface="Helvetica" pitchFamily="34" charset="-120"/>
+                <a:latin typeface="Century Gothic" pitchFamily="34" charset="0"/>
+                <a:ea typeface="Century Gothic" pitchFamily="34" charset="-122"/>
+                <a:cs typeface="Century Gothic" pitchFamily="34" charset="-120"/>
               </a:rPr>
               <a:t>Верстка страницы</a:t>
             </a:r>
@@ -2445,9 +2445,9 @@
                 <a:solidFill>
                   <a:srgbClr val="FFFFFF"/>
                 </a:solidFill>
-                <a:latin typeface="Helvetica" pitchFamily="34" charset="0"/>
-                <a:ea typeface="Helvetica" pitchFamily="34" charset="-122"/>
-                <a:cs typeface="Helvetica" pitchFamily="34" charset="-120"/>
+                <a:latin typeface="Century Gothic" pitchFamily="34" charset="0"/>
+                <a:ea typeface="Century Gothic" pitchFamily="34" charset="-122"/>
+                <a:cs typeface="Century Gothic" pitchFamily="34" charset="-120"/>
               </a:rPr>
               <a:t>Верстка</a:t>
             </a:r>
@@ -2480,13 +2480,211 @@
       </p:sp>
       <p:sp>
         <p:nvSpPr>
-          <p:cNvPr id="53" name="Shape 51"/>
-          <p:cNvSpPr/>
-          <p:nvPr/>
-        </p:nvSpPr>
-        <p:spPr>
-          <a:xfrm>
-            <a:off x="431800" y="1739900"/>
+          <p:cNvPr id="53" name="Text 51"/>
+          <p:cNvSpPr/>
+          <p:nvPr/>
+        </p:nvSpPr>
+        <p:spPr>
+          <a:xfrm>
+            <a:off x="622300" y="1771650"/>
+            <a:ext cx="2527300" cy="133350"/>
+          </a:xfrm>
+          <a:prstGeom prst="rect">
+            <a:avLst/>
+          </a:prstGeom>
+          <a:noFill/>
+          <a:ln/>
+        </p:spPr>
+        <p:txBody>
+          <a:bodyPr wrap="square" lIns="0" tIns="0" rIns="0" bIns="0" rtlCol="0" anchor="ctr"/>
+          <a:lstStyle/>
+          <a:p>
+            <a:pPr algn="l" indent="0" marL="0">
+              <a:buNone/>
+            </a:pPr>
+            <a:r>
+              <a:rPr lang="en-US" sz="1200" b="1" dirty="0">
+                <a:solidFill>
+                  <a:srgbClr val="866941"/>
+                </a:solidFill>
+                <a:latin typeface="Century Gothic" pitchFamily="34" charset="0"/>
+                <a:ea typeface="Century Gothic" pitchFamily="34" charset="-122"/>
+                <a:cs typeface="Century Gothic" pitchFamily="34" charset="-120"/>
+              </a:rPr>
+              <a:t>Текучка</a:t>
+            </a:r>
+            <a:endParaRPr lang="en-US" sz="1200" dirty="0"/>
+          </a:p>
+        </p:txBody>
+      </p:sp>
+      <p:sp>
+        <p:nvSpPr>
+          <p:cNvPr id="54" name="Shape 52"/>
+          <p:cNvSpPr/>
+          <p:nvPr/>
+        </p:nvSpPr>
+        <p:spPr>
+          <a:xfrm>
+            <a:off x="3321050" y="1771650"/>
+            <a:ext cx="574221" cy="120650"/>
+          </a:xfrm>
+          <a:prstGeom prst="roundRect">
+            <a:avLst>
+              <a:gd name="adj" fmla="val 21053"/>
+            </a:avLst>
+          </a:prstGeom>
+          <a:solidFill>
+            <a:srgbClr val="A98959"/>
+          </a:solidFill>
+          <a:ln w="12700">
+            <a:solidFill>
+              <a:srgbClr val="A98959">
+                <a:alpha val="0"/>
+              </a:srgbClr>
+            </a:solidFill>
+            <a:prstDash val="solid"/>
+          </a:ln>
+        </p:spPr>
+      </p:sp>
+      <p:sp>
+        <p:nvSpPr>
+          <p:cNvPr id="55" name="Text 53"/>
+          <p:cNvSpPr/>
+          <p:nvPr/>
+        </p:nvSpPr>
+        <p:spPr>
+          <a:xfrm>
+            <a:off x="3365500" y="1784350"/>
+            <a:ext cx="485321" cy="95250"/>
+          </a:xfrm>
+          <a:prstGeom prst="rect">
+            <a:avLst/>
+          </a:prstGeom>
+          <a:noFill/>
+          <a:ln/>
+        </p:spPr>
+        <p:txBody>
+          <a:bodyPr wrap="square" lIns="0" tIns="0" rIns="0" bIns="0" rtlCol="0" anchor="ctr"/>
+          <a:lstStyle/>
+          <a:p>
+            <a:pPr algn="l" indent="0" marL="0">
+              <a:buNone/>
+            </a:pPr>
+            <a:r>
+              <a:rPr lang="en-US" sz="900" b="1" dirty="0">
+                <a:solidFill>
+                  <a:srgbClr val="FFFFFF"/>
+                </a:solidFill>
+                <a:latin typeface="Century Gothic" pitchFamily="34" charset="0"/>
+                <a:ea typeface="Century Gothic" pitchFamily="34" charset="-122"/>
+                <a:cs typeface="Century Gothic" pitchFamily="34" charset="-120"/>
+              </a:rPr>
+              <a:t>Тек</a:t>
+            </a:r>
+            <a:endParaRPr lang="en-US" sz="900" dirty="0"/>
+          </a:p>
+        </p:txBody>
+      </p:sp>
+      <p:sp>
+        <p:nvSpPr>
+          <p:cNvPr id="56" name="Shape 54"/>
+          <p:cNvSpPr/>
+          <p:nvPr/>
+        </p:nvSpPr>
+        <p:spPr>
+          <a:xfrm>
+            <a:off x="7607300" y="1771650"/>
+            <a:ext cx="574221" cy="120650"/>
+          </a:xfrm>
+          <a:prstGeom prst="roundRect">
+            <a:avLst>
+              <a:gd name="adj" fmla="val 21053"/>
+            </a:avLst>
+          </a:prstGeom>
+          <a:solidFill>
+            <a:srgbClr val="A98959"/>
+          </a:solidFill>
+          <a:ln w="12700">
+            <a:solidFill>
+              <a:srgbClr val="A98959">
+                <a:alpha val="0"/>
+              </a:srgbClr>
+            </a:solidFill>
+            <a:prstDash val="solid"/>
+          </a:ln>
+        </p:spPr>
+      </p:sp>
+      <p:sp>
+        <p:nvSpPr>
+          <p:cNvPr id="57" name="Text 55"/>
+          <p:cNvSpPr/>
+          <p:nvPr/>
+        </p:nvSpPr>
+        <p:spPr>
+          <a:xfrm>
+            <a:off x="7651750" y="1784350"/>
+            <a:ext cx="485321" cy="95250"/>
+          </a:xfrm>
+          <a:prstGeom prst="rect">
+            <a:avLst/>
+          </a:prstGeom>
+          <a:noFill/>
+          <a:ln/>
+        </p:spPr>
+        <p:txBody>
+          <a:bodyPr wrap="square" lIns="0" tIns="0" rIns="0" bIns="0" rtlCol="0" anchor="ctr"/>
+          <a:lstStyle/>
+          <a:p>
+            <a:pPr algn="l" indent="0" marL="0">
+              <a:buNone/>
+            </a:pPr>
+            <a:r>
+              <a:rPr lang="en-US" sz="900" b="1" dirty="0">
+                <a:solidFill>
+                  <a:srgbClr val="FFFFFF"/>
+                </a:solidFill>
+                <a:latin typeface="Century Gothic" pitchFamily="34" charset="0"/>
+                <a:ea typeface="Century Gothic" pitchFamily="34" charset="-122"/>
+                <a:cs typeface="Century Gothic" pitchFamily="34" charset="-120"/>
+              </a:rPr>
+              <a:t>Тек</a:t>
+            </a:r>
+            <a:endParaRPr lang="en-US" sz="900" dirty="0"/>
+          </a:p>
+        </p:txBody>
+      </p:sp>
+      <p:sp>
+        <p:nvSpPr>
+          <p:cNvPr id="58" name="Shape 56"/>
+          <p:cNvSpPr/>
+          <p:nvPr/>
+        </p:nvSpPr>
+        <p:spPr>
+          <a:xfrm>
+            <a:off x="431800" y="1917700"/>
+            <a:ext cx="11442700" cy="0"/>
+          </a:xfrm>
+          <a:prstGeom prst="line">
+            <a:avLst/>
+          </a:prstGeom>
+          <a:noFill/>
+          <a:ln w="7620">
+            <a:solidFill>
+              <a:srgbClr val="E3ECE5"/>
+            </a:solidFill>
+            <a:prstDash val="solid"/>
+          </a:ln>
+        </p:spPr>
+      </p:sp>
+      <p:sp>
+        <p:nvSpPr>
+          <p:cNvPr id="59" name="Shape 57"/>
+          <p:cNvSpPr/>
+          <p:nvPr/>
+        </p:nvSpPr>
+        <p:spPr>
+          <a:xfrm>
+            <a:off x="431800" y="1917700"/>
             <a:ext cx="11442700" cy="177800"/>
           </a:xfrm>
           <a:prstGeom prst="rect">
@@ -2507,13 +2705,13 @@
       </p:sp>
       <p:sp>
         <p:nvSpPr>
-          <p:cNvPr id="54" name="Text 52"/>
-          <p:cNvSpPr/>
-          <p:nvPr/>
-        </p:nvSpPr>
-        <p:spPr>
-          <a:xfrm>
-            <a:off x="508000" y="1765300"/>
+          <p:cNvPr id="60" name="Text 58"/>
+          <p:cNvSpPr/>
+          <p:nvPr/>
+        </p:nvSpPr>
+        <p:spPr>
+          <a:xfrm>
+            <a:off x="508000" y="1943100"/>
             <a:ext cx="2095500" cy="139700"/>
           </a:xfrm>
           <a:prstGeom prst="rect">
@@ -2534,9 +2732,9 @@
                 <a:solidFill>
                   <a:srgbClr val="183A30"/>
                 </a:solidFill>
-                <a:latin typeface="Helvetica" pitchFamily="34" charset="0"/>
-                <a:ea typeface="Helvetica" pitchFamily="34" charset="-122"/>
-                <a:cs typeface="Helvetica" pitchFamily="34" charset="-120"/>
+                <a:latin typeface="Century Gothic" pitchFamily="34" charset="0"/>
+                <a:ea typeface="Century Gothic" pitchFamily="34" charset="-122"/>
+                <a:cs typeface="Century Gothic" pitchFamily="34" charset="-120"/>
               </a:rPr>
               <a:t>Сотрудник 2</a:t>
             </a:r>
@@ -2546,13 +2744,13 @@
       </p:sp>
       <p:sp>
         <p:nvSpPr>
-          <p:cNvPr id="55" name="Text 53"/>
-          <p:cNvSpPr/>
-          <p:nvPr/>
-        </p:nvSpPr>
-        <p:spPr>
-          <a:xfrm>
-            <a:off x="2349500" y="1771650"/>
+          <p:cNvPr id="61" name="Text 59"/>
+          <p:cNvSpPr/>
+          <p:nvPr/>
+        </p:nvSpPr>
+        <p:spPr>
+          <a:xfrm>
+            <a:off x="2349500" y="1949450"/>
             <a:ext cx="762000" cy="127000"/>
           </a:xfrm>
           <a:prstGeom prst="rect">
@@ -2573,9 +2771,9 @@
                 <a:solidFill>
                   <a:srgbClr val="6E8678"/>
                 </a:solidFill>
-                <a:latin typeface="Helvetica" pitchFamily="34" charset="0"/>
-                <a:ea typeface="Helvetica" pitchFamily="34" charset="-122"/>
-                <a:cs typeface="Helvetica" pitchFamily="34" charset="-120"/>
+                <a:latin typeface="Century Gothic" pitchFamily="34" charset="0"/>
+                <a:ea typeface="Century Gothic" pitchFamily="34" charset="-122"/>
+                <a:cs typeface="Century Gothic" pitchFamily="34" charset="-120"/>
               </a:rPr>
               <a:t>ВЕРСТКА</a:t>
             </a:r>
@@ -2585,13 +2783,13 @@
       </p:sp>
       <p:sp>
         <p:nvSpPr>
-          <p:cNvPr id="56" name="Shape 54"/>
-          <p:cNvSpPr/>
-          <p:nvPr/>
-        </p:nvSpPr>
-        <p:spPr>
-          <a:xfrm>
-            <a:off x="431800" y="1917700"/>
+          <p:cNvPr id="62" name="Shape 60"/>
+          <p:cNvSpPr/>
+          <p:nvPr/>
+        </p:nvSpPr>
+        <p:spPr>
+          <a:xfrm>
+            <a:off x="431800" y="2095500"/>
             <a:ext cx="11442700" cy="0"/>
           </a:xfrm>
           <a:prstGeom prst="line">
@@ -2608,13 +2806,211 @@
       </p:sp>
       <p:sp>
         <p:nvSpPr>
-          <p:cNvPr id="57" name="Shape 55"/>
-          <p:cNvSpPr/>
-          <p:nvPr/>
-        </p:nvSpPr>
-        <p:spPr>
-          <a:xfrm>
-            <a:off x="431800" y="1917700"/>
+          <p:cNvPr id="63" name="Text 61"/>
+          <p:cNvSpPr/>
+          <p:nvPr/>
+        </p:nvSpPr>
+        <p:spPr>
+          <a:xfrm>
+            <a:off x="622300" y="2127250"/>
+            <a:ext cx="2527300" cy="133350"/>
+          </a:xfrm>
+          <a:prstGeom prst="rect">
+            <a:avLst/>
+          </a:prstGeom>
+          <a:noFill/>
+          <a:ln/>
+        </p:spPr>
+        <p:txBody>
+          <a:bodyPr wrap="square" lIns="0" tIns="0" rIns="0" bIns="0" rtlCol="0" anchor="ctr"/>
+          <a:lstStyle/>
+          <a:p>
+            <a:pPr algn="l" indent="0" marL="0">
+              <a:buNone/>
+            </a:pPr>
+            <a:r>
+              <a:rPr lang="en-US" sz="1200" b="1" dirty="0">
+                <a:solidFill>
+                  <a:srgbClr val="866941"/>
+                </a:solidFill>
+                <a:latin typeface="Century Gothic" pitchFamily="34" charset="0"/>
+                <a:ea typeface="Century Gothic" pitchFamily="34" charset="-122"/>
+                <a:cs typeface="Century Gothic" pitchFamily="34" charset="-120"/>
+              </a:rPr>
+              <a:t>Текучка</a:t>
+            </a:r>
+            <a:endParaRPr lang="en-US" sz="1200" dirty="0"/>
+          </a:p>
+        </p:txBody>
+      </p:sp>
+      <p:sp>
+        <p:nvSpPr>
+          <p:cNvPr id="64" name="Shape 62"/>
+          <p:cNvSpPr/>
+          <p:nvPr/>
+        </p:nvSpPr>
+        <p:spPr>
+          <a:xfrm>
+            <a:off x="3933371" y="2127250"/>
+            <a:ext cx="574221" cy="120650"/>
+          </a:xfrm>
+          <a:prstGeom prst="roundRect">
+            <a:avLst>
+              <a:gd name="adj" fmla="val 21053"/>
+            </a:avLst>
+          </a:prstGeom>
+          <a:solidFill>
+            <a:srgbClr val="A98959"/>
+          </a:solidFill>
+          <a:ln w="12700">
+            <a:solidFill>
+              <a:srgbClr val="A98959">
+                <a:alpha val="0"/>
+              </a:srgbClr>
+            </a:solidFill>
+            <a:prstDash val="solid"/>
+          </a:ln>
+        </p:spPr>
+      </p:sp>
+      <p:sp>
+        <p:nvSpPr>
+          <p:cNvPr id="65" name="Text 63"/>
+          <p:cNvSpPr/>
+          <p:nvPr/>
+        </p:nvSpPr>
+        <p:spPr>
+          <a:xfrm>
+            <a:off x="3977821" y="2139950"/>
+            <a:ext cx="485321" cy="95250"/>
+          </a:xfrm>
+          <a:prstGeom prst="rect">
+            <a:avLst/>
+          </a:prstGeom>
+          <a:noFill/>
+          <a:ln/>
+        </p:spPr>
+        <p:txBody>
+          <a:bodyPr wrap="square" lIns="0" tIns="0" rIns="0" bIns="0" rtlCol="0" anchor="ctr"/>
+          <a:lstStyle/>
+          <a:p>
+            <a:pPr algn="l" indent="0" marL="0">
+              <a:buNone/>
+            </a:pPr>
+            <a:r>
+              <a:rPr lang="en-US" sz="900" b="1" dirty="0">
+                <a:solidFill>
+                  <a:srgbClr val="FFFFFF"/>
+                </a:solidFill>
+                <a:latin typeface="Century Gothic" pitchFamily="34" charset="0"/>
+                <a:ea typeface="Century Gothic" pitchFamily="34" charset="-122"/>
+                <a:cs typeface="Century Gothic" pitchFamily="34" charset="-120"/>
+              </a:rPr>
+              <a:t>Тек</a:t>
+            </a:r>
+            <a:endParaRPr lang="en-US" sz="900" dirty="0"/>
+          </a:p>
+        </p:txBody>
+      </p:sp>
+      <p:sp>
+        <p:nvSpPr>
+          <p:cNvPr id="66" name="Shape 64"/>
+          <p:cNvSpPr/>
+          <p:nvPr/>
+        </p:nvSpPr>
+        <p:spPr>
+          <a:xfrm>
+            <a:off x="8219621" y="2127250"/>
+            <a:ext cx="574221" cy="120650"/>
+          </a:xfrm>
+          <a:prstGeom prst="roundRect">
+            <a:avLst>
+              <a:gd name="adj" fmla="val 21053"/>
+            </a:avLst>
+          </a:prstGeom>
+          <a:solidFill>
+            <a:srgbClr val="A98959"/>
+          </a:solidFill>
+          <a:ln w="12700">
+            <a:solidFill>
+              <a:srgbClr val="A98959">
+                <a:alpha val="0"/>
+              </a:srgbClr>
+            </a:solidFill>
+            <a:prstDash val="solid"/>
+          </a:ln>
+        </p:spPr>
+      </p:sp>
+      <p:sp>
+        <p:nvSpPr>
+          <p:cNvPr id="67" name="Text 65"/>
+          <p:cNvSpPr/>
+          <p:nvPr/>
+        </p:nvSpPr>
+        <p:spPr>
+          <a:xfrm>
+            <a:off x="8264071" y="2139950"/>
+            <a:ext cx="485321" cy="95250"/>
+          </a:xfrm>
+          <a:prstGeom prst="rect">
+            <a:avLst/>
+          </a:prstGeom>
+          <a:noFill/>
+          <a:ln/>
+        </p:spPr>
+        <p:txBody>
+          <a:bodyPr wrap="square" lIns="0" tIns="0" rIns="0" bIns="0" rtlCol="0" anchor="ctr"/>
+          <a:lstStyle/>
+          <a:p>
+            <a:pPr algn="l" indent="0" marL="0">
+              <a:buNone/>
+            </a:pPr>
+            <a:r>
+              <a:rPr lang="en-US" sz="900" b="1" dirty="0">
+                <a:solidFill>
+                  <a:srgbClr val="FFFFFF"/>
+                </a:solidFill>
+                <a:latin typeface="Century Gothic" pitchFamily="34" charset="0"/>
+                <a:ea typeface="Century Gothic" pitchFamily="34" charset="-122"/>
+                <a:cs typeface="Century Gothic" pitchFamily="34" charset="-120"/>
+              </a:rPr>
+              <a:t>Тек</a:t>
+            </a:r>
+            <a:endParaRPr lang="en-US" sz="900" dirty="0"/>
+          </a:p>
+        </p:txBody>
+      </p:sp>
+      <p:sp>
+        <p:nvSpPr>
+          <p:cNvPr id="68" name="Shape 66"/>
+          <p:cNvSpPr/>
+          <p:nvPr/>
+        </p:nvSpPr>
+        <p:spPr>
+          <a:xfrm>
+            <a:off x="431800" y="2273300"/>
+            <a:ext cx="11442700" cy="0"/>
+          </a:xfrm>
+          <a:prstGeom prst="line">
+            <a:avLst/>
+          </a:prstGeom>
+          <a:noFill/>
+          <a:ln w="7620">
+            <a:solidFill>
+              <a:srgbClr val="E3ECE5"/>
+            </a:solidFill>
+            <a:prstDash val="solid"/>
+          </a:ln>
+        </p:spPr>
+      </p:sp>
+      <p:sp>
+        <p:nvSpPr>
+          <p:cNvPr id="69" name="Shape 67"/>
+          <p:cNvSpPr/>
+          <p:nvPr/>
+        </p:nvSpPr>
+        <p:spPr>
+          <a:xfrm>
+            <a:off x="431800" y="2273300"/>
             <a:ext cx="11442700" cy="177800"/>
           </a:xfrm>
           <a:prstGeom prst="rect">
@@ -2635,13 +3031,13 @@
       </p:sp>
       <p:sp>
         <p:nvSpPr>
-          <p:cNvPr id="58" name="Text 56"/>
-          <p:cNvSpPr/>
-          <p:nvPr/>
-        </p:nvSpPr>
-        <p:spPr>
-          <a:xfrm>
-            <a:off x="508000" y="1943100"/>
+          <p:cNvPr id="70" name="Text 68"/>
+          <p:cNvSpPr/>
+          <p:nvPr/>
+        </p:nvSpPr>
+        <p:spPr>
+          <a:xfrm>
+            <a:off x="508000" y="2298700"/>
             <a:ext cx="2095500" cy="139700"/>
           </a:xfrm>
           <a:prstGeom prst="rect">
@@ -2662,9 +3058,9 @@
                 <a:solidFill>
                   <a:srgbClr val="183A30"/>
                 </a:solidFill>
-                <a:latin typeface="Helvetica" pitchFamily="34" charset="0"/>
-                <a:ea typeface="Helvetica" pitchFamily="34" charset="-122"/>
-                <a:cs typeface="Helvetica" pitchFamily="34" charset="-120"/>
+                <a:latin typeface="Century Gothic" pitchFamily="34" charset="0"/>
+                <a:ea typeface="Century Gothic" pitchFamily="34" charset="-122"/>
+                <a:cs typeface="Century Gothic" pitchFamily="34" charset="-120"/>
               </a:rPr>
               <a:t>Сотрудник 3</a:t>
             </a:r>
@@ -2674,13 +3070,13 @@
       </p:sp>
       <p:sp>
         <p:nvSpPr>
-          <p:cNvPr id="59" name="Text 57"/>
-          <p:cNvSpPr/>
-          <p:nvPr/>
-        </p:nvSpPr>
-        <p:spPr>
-          <a:xfrm>
-            <a:off x="2349500" y="1949450"/>
+          <p:cNvPr id="71" name="Text 69"/>
+          <p:cNvSpPr/>
+          <p:nvPr/>
+        </p:nvSpPr>
+        <p:spPr>
+          <a:xfrm>
+            <a:off x="2349500" y="2305050"/>
             <a:ext cx="762000" cy="127000"/>
           </a:xfrm>
           <a:prstGeom prst="rect">
@@ -2701,9 +3097,9 @@
                 <a:solidFill>
                   <a:srgbClr val="6E8678"/>
                 </a:solidFill>
-                <a:latin typeface="Helvetica" pitchFamily="34" charset="0"/>
-                <a:ea typeface="Helvetica" pitchFamily="34" charset="-122"/>
-                <a:cs typeface="Helvetica" pitchFamily="34" charset="-120"/>
+                <a:latin typeface="Century Gothic" pitchFamily="34" charset="0"/>
+                <a:ea typeface="Century Gothic" pitchFamily="34" charset="-122"/>
+                <a:cs typeface="Century Gothic" pitchFamily="34" charset="-120"/>
               </a:rPr>
               <a:t>ДИЗАЙН</a:t>
             </a:r>
@@ -2713,13 +3109,13 @@
       </p:sp>
       <p:sp>
         <p:nvSpPr>
-          <p:cNvPr id="60" name="Shape 58"/>
-          <p:cNvSpPr/>
-          <p:nvPr/>
-        </p:nvSpPr>
-        <p:spPr>
-          <a:xfrm>
-            <a:off x="431800" y="2095500"/>
+          <p:cNvPr id="72" name="Shape 70"/>
+          <p:cNvSpPr/>
+          <p:nvPr/>
+        </p:nvSpPr>
+        <p:spPr>
+          <a:xfrm>
+            <a:off x="431800" y="2451100"/>
             <a:ext cx="11442700" cy="0"/>
           </a:xfrm>
           <a:prstGeom prst="line">
@@ -2736,13 +3132,13 @@
       </p:sp>
       <p:sp>
         <p:nvSpPr>
-          <p:cNvPr id="61" name="Text 59"/>
-          <p:cNvSpPr/>
-          <p:nvPr/>
-        </p:nvSpPr>
-        <p:spPr>
-          <a:xfrm>
-            <a:off x="622300" y="2127250"/>
+          <p:cNvPr id="73" name="Text 71"/>
+          <p:cNvSpPr/>
+          <p:nvPr/>
+        </p:nvSpPr>
+        <p:spPr>
+          <a:xfrm>
+            <a:off x="622300" y="2482850"/>
             <a:ext cx="2527300" cy="133350"/>
           </a:xfrm>
           <a:prstGeom prst="rect">
@@ -2763,9 +3159,9 @@
                 <a:solidFill>
                   <a:srgbClr val="183A30"/>
                 </a:solidFill>
-                <a:latin typeface="Helvetica" pitchFamily="34" charset="0"/>
-                <a:ea typeface="Helvetica" pitchFamily="34" charset="-122"/>
-                <a:cs typeface="Helvetica" pitchFamily="34" charset="-120"/>
+                <a:latin typeface="Century Gothic" pitchFamily="34" charset="0"/>
+                <a:ea typeface="Century Gothic" pitchFamily="34" charset="-122"/>
+                <a:cs typeface="Century Gothic" pitchFamily="34" charset="-120"/>
               </a:rPr>
               <a:t>Дизайн страницы</a:t>
             </a:r>
@@ -2775,13 +3171,13 @@
       </p:sp>
       <p:sp>
         <p:nvSpPr>
-          <p:cNvPr id="62" name="Shape 60"/>
-          <p:cNvSpPr/>
-          <p:nvPr/>
-        </p:nvSpPr>
-        <p:spPr>
-          <a:xfrm>
-            <a:off x="3321050" y="2127250"/>
+          <p:cNvPr id="74" name="Shape 72"/>
+          <p:cNvSpPr/>
+          <p:nvPr/>
+        </p:nvSpPr>
+        <p:spPr>
+          <a:xfrm>
+            <a:off x="3321050" y="2482850"/>
             <a:ext cx="1798864" cy="120650"/>
           </a:xfrm>
           <a:prstGeom prst="roundRect">
@@ -2804,13 +3200,13 @@
       </p:sp>
       <p:sp>
         <p:nvSpPr>
-          <p:cNvPr id="63" name="Text 61"/>
-          <p:cNvSpPr/>
-          <p:nvPr/>
-        </p:nvSpPr>
-        <p:spPr>
-          <a:xfrm>
-            <a:off x="3365500" y="2139950"/>
+          <p:cNvPr id="75" name="Text 73"/>
+          <p:cNvSpPr/>
+          <p:nvPr/>
+        </p:nvSpPr>
+        <p:spPr>
+          <a:xfrm>
+            <a:off x="3365500" y="2495550"/>
             <a:ext cx="1709964" cy="95250"/>
           </a:xfrm>
           <a:prstGeom prst="rect">
@@ -2831,9 +3227,9 @@
                 <a:solidFill>
                   <a:srgbClr val="FFFFFF"/>
                 </a:solidFill>
-                <a:latin typeface="Helvetica" pitchFamily="34" charset="0"/>
-                <a:ea typeface="Helvetica" pitchFamily="34" charset="-122"/>
-                <a:cs typeface="Helvetica" pitchFamily="34" charset="-120"/>
+                <a:latin typeface="Century Gothic" pitchFamily="34" charset="0"/>
+                <a:ea typeface="Century Gothic" pitchFamily="34" charset="-122"/>
+                <a:cs typeface="Century Gothic" pitchFamily="34" charset="-120"/>
               </a:rPr>
               <a:t>Дизайн</a:t>
             </a:r>
@@ -2843,13 +3239,13 @@
       </p:sp>
       <p:sp>
         <p:nvSpPr>
-          <p:cNvPr id="64" name="Shape 62"/>
-          <p:cNvSpPr/>
-          <p:nvPr/>
-        </p:nvSpPr>
-        <p:spPr>
-          <a:xfrm>
-            <a:off x="431800" y="2273300"/>
+          <p:cNvPr id="76" name="Shape 74"/>
+          <p:cNvSpPr/>
+          <p:nvPr/>
+        </p:nvSpPr>
+        <p:spPr>
+          <a:xfrm>
+            <a:off x="431800" y="2628900"/>
             <a:ext cx="11442700" cy="0"/>
           </a:xfrm>
           <a:prstGeom prst="line">
@@ -2866,7 +3262,205 @@
       </p:sp>
       <p:sp>
         <p:nvSpPr>
-          <p:cNvPr id="65" name="Text 63"/>
+          <p:cNvPr id="77" name="Text 75"/>
+          <p:cNvSpPr/>
+          <p:nvPr/>
+        </p:nvSpPr>
+        <p:spPr>
+          <a:xfrm>
+            <a:off x="622300" y="2660650"/>
+            <a:ext cx="2527300" cy="133350"/>
+          </a:xfrm>
+          <a:prstGeom prst="rect">
+            <a:avLst/>
+          </a:prstGeom>
+          <a:noFill/>
+          <a:ln/>
+        </p:spPr>
+        <p:txBody>
+          <a:bodyPr wrap="square" lIns="0" tIns="0" rIns="0" bIns="0" rtlCol="0" anchor="ctr"/>
+          <a:lstStyle/>
+          <a:p>
+            <a:pPr algn="l" indent="0" marL="0">
+              <a:buNone/>
+            </a:pPr>
+            <a:r>
+              <a:rPr lang="en-US" sz="1200" b="1" dirty="0">
+                <a:solidFill>
+                  <a:srgbClr val="866941"/>
+                </a:solidFill>
+                <a:latin typeface="Century Gothic" pitchFamily="34" charset="0"/>
+                <a:ea typeface="Century Gothic" pitchFamily="34" charset="-122"/>
+                <a:cs typeface="Century Gothic" pitchFamily="34" charset="-120"/>
+              </a:rPr>
+              <a:t>Текучка</a:t>
+            </a:r>
+            <a:endParaRPr lang="en-US" sz="1200" dirty="0"/>
+          </a:p>
+        </p:txBody>
+      </p:sp>
+      <p:sp>
+        <p:nvSpPr>
+          <p:cNvPr id="78" name="Shape 76"/>
+          <p:cNvSpPr/>
+          <p:nvPr/>
+        </p:nvSpPr>
+        <p:spPr>
+          <a:xfrm>
+            <a:off x="4545693" y="2660650"/>
+            <a:ext cx="574221" cy="120650"/>
+          </a:xfrm>
+          <a:prstGeom prst="roundRect">
+            <a:avLst>
+              <a:gd name="adj" fmla="val 21053"/>
+            </a:avLst>
+          </a:prstGeom>
+          <a:solidFill>
+            <a:srgbClr val="A98959"/>
+          </a:solidFill>
+          <a:ln w="12700">
+            <a:solidFill>
+              <a:srgbClr val="A98959">
+                <a:alpha val="0"/>
+              </a:srgbClr>
+            </a:solidFill>
+            <a:prstDash val="solid"/>
+          </a:ln>
+        </p:spPr>
+      </p:sp>
+      <p:sp>
+        <p:nvSpPr>
+          <p:cNvPr id="79" name="Text 77"/>
+          <p:cNvSpPr/>
+          <p:nvPr/>
+        </p:nvSpPr>
+        <p:spPr>
+          <a:xfrm>
+            <a:off x="4590143" y="2673350"/>
+            <a:ext cx="485321" cy="95250"/>
+          </a:xfrm>
+          <a:prstGeom prst="rect">
+            <a:avLst/>
+          </a:prstGeom>
+          <a:noFill/>
+          <a:ln/>
+        </p:spPr>
+        <p:txBody>
+          <a:bodyPr wrap="square" lIns="0" tIns="0" rIns="0" bIns="0" rtlCol="0" anchor="ctr"/>
+          <a:lstStyle/>
+          <a:p>
+            <a:pPr algn="l" indent="0" marL="0">
+              <a:buNone/>
+            </a:pPr>
+            <a:r>
+              <a:rPr lang="en-US" sz="900" b="1" dirty="0">
+                <a:solidFill>
+                  <a:srgbClr val="FFFFFF"/>
+                </a:solidFill>
+                <a:latin typeface="Century Gothic" pitchFamily="34" charset="0"/>
+                <a:ea typeface="Century Gothic" pitchFamily="34" charset="-122"/>
+                <a:cs typeface="Century Gothic" pitchFamily="34" charset="-120"/>
+              </a:rPr>
+              <a:t>Тек</a:t>
+            </a:r>
+            <a:endParaRPr lang="en-US" sz="900" dirty="0"/>
+          </a:p>
+        </p:txBody>
+      </p:sp>
+      <p:sp>
+        <p:nvSpPr>
+          <p:cNvPr id="80" name="Shape 78"/>
+          <p:cNvSpPr/>
+          <p:nvPr/>
+        </p:nvSpPr>
+        <p:spPr>
+          <a:xfrm>
+            <a:off x="8831943" y="2660650"/>
+            <a:ext cx="574221" cy="120650"/>
+          </a:xfrm>
+          <a:prstGeom prst="roundRect">
+            <a:avLst>
+              <a:gd name="adj" fmla="val 21053"/>
+            </a:avLst>
+          </a:prstGeom>
+          <a:solidFill>
+            <a:srgbClr val="A98959"/>
+          </a:solidFill>
+          <a:ln w="12700">
+            <a:solidFill>
+              <a:srgbClr val="A98959">
+                <a:alpha val="0"/>
+              </a:srgbClr>
+            </a:solidFill>
+            <a:prstDash val="solid"/>
+          </a:ln>
+        </p:spPr>
+      </p:sp>
+      <p:sp>
+        <p:nvSpPr>
+          <p:cNvPr id="81" name="Text 79"/>
+          <p:cNvSpPr/>
+          <p:nvPr/>
+        </p:nvSpPr>
+        <p:spPr>
+          <a:xfrm>
+            <a:off x="8876393" y="2673350"/>
+            <a:ext cx="485321" cy="95250"/>
+          </a:xfrm>
+          <a:prstGeom prst="rect">
+            <a:avLst/>
+          </a:prstGeom>
+          <a:noFill/>
+          <a:ln/>
+        </p:spPr>
+        <p:txBody>
+          <a:bodyPr wrap="square" lIns="0" tIns="0" rIns="0" bIns="0" rtlCol="0" anchor="ctr"/>
+          <a:lstStyle/>
+          <a:p>
+            <a:pPr algn="l" indent="0" marL="0">
+              <a:buNone/>
+            </a:pPr>
+            <a:r>
+              <a:rPr lang="en-US" sz="900" b="1" dirty="0">
+                <a:solidFill>
+                  <a:srgbClr val="FFFFFF"/>
+                </a:solidFill>
+                <a:latin typeface="Century Gothic" pitchFamily="34" charset="0"/>
+                <a:ea typeface="Century Gothic" pitchFamily="34" charset="-122"/>
+                <a:cs typeface="Century Gothic" pitchFamily="34" charset="-120"/>
+              </a:rPr>
+              <a:t>Тек</a:t>
+            </a:r>
+            <a:endParaRPr lang="en-US" sz="900" dirty="0"/>
+          </a:p>
+        </p:txBody>
+      </p:sp>
+      <p:sp>
+        <p:nvSpPr>
+          <p:cNvPr id="82" name="Shape 80"/>
+          <p:cNvSpPr/>
+          <p:nvPr/>
+        </p:nvSpPr>
+        <p:spPr>
+          <a:xfrm>
+            <a:off x="431800" y="2806700"/>
+            <a:ext cx="11442700" cy="0"/>
+          </a:xfrm>
+          <a:prstGeom prst="line">
+            <a:avLst/>
+          </a:prstGeom>
+          <a:noFill/>
+          <a:ln w="7620">
+            <a:solidFill>
+              <a:srgbClr val="E3ECE5"/>
+            </a:solidFill>
+            <a:prstDash val="solid"/>
+          </a:ln>
+        </p:spPr>
+      </p:sp>
+      <p:sp>
+        <p:nvSpPr>
+          <p:cNvPr id="83" name="Text 81"/>
           <p:cNvSpPr/>
           <p:nvPr/>
         </p:nvSpPr>
@@ -2893,9 +3487,9 @@
                 <a:solidFill>
                   <a:srgbClr val="6E8678"/>
                 </a:solidFill>
-                <a:latin typeface="Helvetica" pitchFamily="34" charset="0"/>
-                <a:ea typeface="Helvetica" pitchFamily="34" charset="-122"/>
-                <a:cs typeface="Helvetica" pitchFamily="34" charset="-120"/>
+                <a:latin typeface="Century Gothic" pitchFamily="34" charset="0"/>
+                <a:ea typeface="Century Gothic" pitchFamily="34" charset="-122"/>
+                <a:cs typeface="Century Gothic" pitchFamily="34" charset="-120"/>
               </a:rPr>
               <a:t>СОСТОЯНИЕ ЗАДАЧ</a:t>
             </a:r>
@@ -2905,7 +3499,7 @@
       </p:sp>
       <p:sp>
         <p:nvSpPr>
-          <p:cNvPr id="66" name="Shape 64"/>
+          <p:cNvPr id="84" name="Shape 82"/>
           <p:cNvSpPr/>
           <p:nvPr/>
         </p:nvSpPr>
@@ -2934,7 +3528,7 @@
       </p:sp>
       <p:sp>
         <p:nvSpPr>
-          <p:cNvPr id="67" name="Text 65"/>
+          <p:cNvPr id="85" name="Text 83"/>
           <p:cNvSpPr/>
           <p:nvPr/>
         </p:nvSpPr>
@@ -2961,9 +3555,9 @@
                 <a:solidFill>
                   <a:srgbClr val="6E8678"/>
                 </a:solidFill>
-                <a:latin typeface="Helvetica" pitchFamily="34" charset="0"/>
-                <a:ea typeface="Helvetica" pitchFamily="34" charset="-122"/>
-                <a:cs typeface="Helvetica" pitchFamily="34" charset="-120"/>
+                <a:latin typeface="Century Gothic" pitchFamily="34" charset="0"/>
+                <a:ea typeface="Century Gothic" pitchFamily="34" charset="-122"/>
+                <a:cs typeface="Century Gothic" pitchFamily="34" charset="-120"/>
               </a:rPr>
               <a:t>Ожидает</a:t>
             </a:r>
@@ -2973,7 +3567,7 @@
       </p:sp>
       <p:sp>
         <p:nvSpPr>
-          <p:cNvPr id="68" name="Shape 66"/>
+          <p:cNvPr id="86" name="Shape 84"/>
           <p:cNvSpPr/>
           <p:nvPr/>
         </p:nvSpPr>
@@ -3002,7 +3596,7 @@
       </p:sp>
       <p:sp>
         <p:nvSpPr>
-          <p:cNvPr id="69" name="Text 67"/>
+          <p:cNvPr id="87" name="Text 85"/>
           <p:cNvSpPr/>
           <p:nvPr/>
         </p:nvSpPr>
@@ -3029,9 +3623,9 @@
                 <a:solidFill>
                   <a:srgbClr val="6E8678"/>
                 </a:solidFill>
-                <a:latin typeface="Helvetica" pitchFamily="34" charset="0"/>
-                <a:ea typeface="Helvetica" pitchFamily="34" charset="-122"/>
-                <a:cs typeface="Helvetica" pitchFamily="34" charset="-120"/>
+                <a:latin typeface="Century Gothic" pitchFamily="34" charset="0"/>
+                <a:ea typeface="Century Gothic" pitchFamily="34" charset="-122"/>
+                <a:cs typeface="Century Gothic" pitchFamily="34" charset="-120"/>
               </a:rPr>
               <a:t>В работе</a:t>
             </a:r>
@@ -3041,7 +3635,7 @@
       </p:sp>
       <p:sp>
         <p:nvSpPr>
-          <p:cNvPr id="70" name="Shape 68"/>
+          <p:cNvPr id="88" name="Shape 86"/>
           <p:cNvSpPr/>
           <p:nvPr/>
         </p:nvSpPr>
@@ -3070,7 +3664,7 @@
       </p:sp>
       <p:sp>
         <p:nvSpPr>
-          <p:cNvPr id="71" name="Text 69"/>
+          <p:cNvPr id="89" name="Text 87"/>
           <p:cNvSpPr/>
           <p:nvPr/>
         </p:nvSpPr>
@@ -3097,9 +3691,9 @@
                 <a:solidFill>
                   <a:srgbClr val="6E8678"/>
                 </a:solidFill>
-                <a:latin typeface="Helvetica" pitchFamily="34" charset="0"/>
-                <a:ea typeface="Helvetica" pitchFamily="34" charset="-122"/>
-                <a:cs typeface="Helvetica" pitchFamily="34" charset="-120"/>
+                <a:latin typeface="Century Gothic" pitchFamily="34" charset="0"/>
+                <a:ea typeface="Century Gothic" pitchFamily="34" charset="-122"/>
+                <a:cs typeface="Century Gothic" pitchFamily="34" charset="-120"/>
               </a:rPr>
               <a:t>Выполнена</a:t>
             </a:r>
@@ -3109,7 +3703,7 @@
       </p:sp>
       <p:sp>
         <p:nvSpPr>
-          <p:cNvPr id="72" name="Shape 70"/>
+          <p:cNvPr id="90" name="Shape 88"/>
           <p:cNvSpPr/>
           <p:nvPr/>
         </p:nvSpPr>
@@ -3138,7 +3732,7 @@
       </p:sp>
       <p:sp>
         <p:nvSpPr>
-          <p:cNvPr id="73" name="Text 71"/>
+          <p:cNvPr id="91" name="Text 89"/>
           <p:cNvSpPr/>
           <p:nvPr/>
         </p:nvSpPr>
@@ -3165,9 +3759,9 @@
                 <a:solidFill>
                   <a:srgbClr val="6E8678"/>
                 </a:solidFill>
-                <a:latin typeface="Helvetica" pitchFamily="34" charset="0"/>
-                <a:ea typeface="Helvetica" pitchFamily="34" charset="-122"/>
-                <a:cs typeface="Helvetica" pitchFamily="34" charset="-120"/>
+                <a:latin typeface="Century Gothic" pitchFamily="34" charset="0"/>
+                <a:ea typeface="Century Gothic" pitchFamily="34" charset="-122"/>
+                <a:cs typeface="Century Gothic" pitchFamily="34" charset="-120"/>
               </a:rPr>
               <a:t>Текучка</a:t>
             </a:r>
@@ -3177,7 +3771,7 @@
       </p:sp>
       <p:sp>
         <p:nvSpPr>
-          <p:cNvPr id="74" name="Text 72"/>
+          <p:cNvPr id="92" name="Text 90"/>
           <p:cNvSpPr/>
           <p:nvPr/>
         </p:nvSpPr>
@@ -3204,9 +3798,9 @@
                 <a:solidFill>
                   <a:srgbClr val="6E8678"/>
                 </a:solidFill>
-                <a:latin typeface="Helvetica" pitchFamily="34" charset="0"/>
-                <a:ea typeface="Helvetica" pitchFamily="34" charset="-122"/>
-                <a:cs typeface="Helvetica" pitchFamily="34" charset="-120"/>
+                <a:latin typeface="Century Gothic" pitchFamily="34" charset="0"/>
+                <a:ea typeface="Century Gothic" pitchFamily="34" charset="-122"/>
+                <a:cs typeface="Century Gothic" pitchFamily="34" charset="-120"/>
               </a:rPr>
               <a:t>1 / 1</a:t>
             </a:r>

</xml_diff>